<commit_message>
Ship mobile-first discovery and permissioned host photo release
</commit_message>
<xml_diff>
--- a/public/ChargeNeighbour-pilot-pitch.pptx
+++ b/public/ChargeNeighbour-pilot-pitch.pptx
@@ -2,22 +2,22 @@
 <file path=ppt/presentation.xml><?xml version="1.0" encoding="utf-8"?>
 <p:presentation xmlns:p="http://schemas.openxmlformats.org/presentationml/2006/main">
   <p:sldMasterIdLst>
-    <p:sldMasterId xmlns:r="http://schemas.openxmlformats.org/officeDocument/2006/relationships" id="2147483648" r:id="R81d844f0dee5467a"/>
+    <p:sldMasterId xmlns:r="http://schemas.openxmlformats.org/officeDocument/2006/relationships" id="2147483648" r:id="Rbb6fac9c3fc84bad"/>
   </p:sldMasterIdLst>
   <p:notesMasterIdLst>
-    <p:notesMasterId xmlns:r="http://schemas.openxmlformats.org/officeDocument/2006/relationships" r:id="Rdee1ea8808a44029"/>
+    <p:notesMasterId xmlns:r="http://schemas.openxmlformats.org/officeDocument/2006/relationships" r:id="R45f7b64d7ccc47a5"/>
   </p:notesMasterIdLst>
   <p:sldIdLst>
-    <p:sldId xmlns:r="http://schemas.openxmlformats.org/officeDocument/2006/relationships" id="256" r:id="R77ca29f76dae4071"/>
-    <p:sldId xmlns:r="http://schemas.openxmlformats.org/officeDocument/2006/relationships" id="257" r:id="R189e81be0d424df8"/>
-    <p:sldId xmlns:r="http://schemas.openxmlformats.org/officeDocument/2006/relationships" id="258" r:id="Ra7a604a0ecab4aae"/>
-    <p:sldId xmlns:r="http://schemas.openxmlformats.org/officeDocument/2006/relationships" id="259" r:id="R49f8a40440354880"/>
-    <p:sldId xmlns:r="http://schemas.openxmlformats.org/officeDocument/2006/relationships" id="260" r:id="R7b14d0585f6b4815"/>
-    <p:sldId xmlns:r="http://schemas.openxmlformats.org/officeDocument/2006/relationships" id="261" r:id="R660a74ebf76b49ab"/>
-    <p:sldId xmlns:r="http://schemas.openxmlformats.org/officeDocument/2006/relationships" id="262" r:id="R3087610daa80409e"/>
-    <p:sldId xmlns:r="http://schemas.openxmlformats.org/officeDocument/2006/relationships" id="263" r:id="Rab89b48b76114a6c"/>
-    <p:sldId xmlns:r="http://schemas.openxmlformats.org/officeDocument/2006/relationships" id="264" r:id="Rf8cbb42005bc473c"/>
-    <p:sldId xmlns:r="http://schemas.openxmlformats.org/officeDocument/2006/relationships" id="265" r:id="R383a952b6da04586"/>
+    <p:sldId xmlns:r="http://schemas.openxmlformats.org/officeDocument/2006/relationships" id="256" r:id="R8c093301cb6c427d"/>
+    <p:sldId xmlns:r="http://schemas.openxmlformats.org/officeDocument/2006/relationships" id="257" r:id="R4129ff5b1a5c4267"/>
+    <p:sldId xmlns:r="http://schemas.openxmlformats.org/officeDocument/2006/relationships" id="258" r:id="R5dd086264c084869"/>
+    <p:sldId xmlns:r="http://schemas.openxmlformats.org/officeDocument/2006/relationships" id="259" r:id="R72c2b1019a8f4eb1"/>
+    <p:sldId xmlns:r="http://schemas.openxmlformats.org/officeDocument/2006/relationships" id="260" r:id="R27303a7a7d784180"/>
+    <p:sldId xmlns:r="http://schemas.openxmlformats.org/officeDocument/2006/relationships" id="261" r:id="R707b9a3ae5574199"/>
+    <p:sldId xmlns:r="http://schemas.openxmlformats.org/officeDocument/2006/relationships" id="262" r:id="R1332f86340214342"/>
+    <p:sldId xmlns:r="http://schemas.openxmlformats.org/officeDocument/2006/relationships" id="263" r:id="Rec066bd0408c4f6f"/>
+    <p:sldId xmlns:r="http://schemas.openxmlformats.org/officeDocument/2006/relationships" id="264" r:id="R3a075cf5fc874182"/>
+    <p:sldId xmlns:r="http://schemas.openxmlformats.org/officeDocument/2006/relationships" id="265" r:id="Rb0e3961071e14f8a"/>
   </p:sldIdLst>
   <p:sldSz cx="12192000" cy="6858000"/>
   <p:notesSz cx="6858000" cy="9144000"/>
@@ -661,7 +661,7 @@
           <a:lstStyle xmlns:a="http://schemas.openxmlformats.org/drawingml/2006/main"/>
           <a:p xmlns:a="http://schemas.openxmlformats.org/drawingml/2006/main">
             <a:r>
-              <a:t>Implementation evidence: https://chargeneighbour-theta.vercel.app , https://chargeneighbour-theta.vercel.app/hosts , https://chargeneighbour-theta.vercel.app/support and the linked repository. Detailed Places cards and synchronized markers still require Google activation. Reservations and payments remain gated pending operator/provider approval and acceptance testing. No operating sessions or partner inventory are claimed.</a:t>
+              <a:t>Current mobile product: https://chargeneighbour-theta.vercel.app . OpenStreetMap/Photon discovery and limited OSRM road routes work without Google billing. Time excludes live traffic. Unknown specifications do not establish compatibility. The demo gallery and fictional reviews are explicitly labelled. Host applications require private photo/GPS evidence and actual manual review. Reservations remain gated. No operating inventory or sessions are claimed.</a:t>
             </a:r>
           </a:p>
         </p:txBody>
@@ -1128,7 +1128,7 @@
           <p:cNvPr id="3" name="Title">
             <a:extLst xmlns:a="http://schemas.openxmlformats.org/drawingml/2006/main">
               <a:ext uri="{FF2B5EF4-FFF2-40B4-BE49-F238E27FC236}">
-                <a16:creationId xmlns:a16="http://schemas.microsoft.com/office/drawing/2014/main" id="{A13F43BD-8518-422C-9F60-F4B845BCCC43}"/>
+                <a16:creationId xmlns:a16="http://schemas.microsoft.com/office/drawing/2014/main" id="{5BD3D00A-F03F-4DD3-8058-C6B43E4928E8}"/>
               </a:ext>
             </a:extLst>
           </p:cNvPr>
@@ -1357,7 +1357,7 @@
           <p:cNvPr id="2" name="Subtitle">
             <a:extLst xmlns:a="http://schemas.openxmlformats.org/drawingml/2006/main">
               <a:ext uri="{FF2B5EF4-FFF2-40B4-BE49-F238E27FC236}">
-                <a16:creationId xmlns:a16="http://schemas.microsoft.com/office/drawing/2014/main" id="{F709EA07-A8B2-4FDC-B55F-0FA416D56082}"/>
+                <a16:creationId xmlns:a16="http://schemas.microsoft.com/office/drawing/2014/main" id="{CEFBA155-65D0-4152-9A4B-4C351A91107F}"/>
               </a:ext>
             </a:extLst>
           </p:cNvPr>
@@ -1603,7 +1603,7 @@
           <p:cNvPr id="2" name="Section title">
             <a:extLst xmlns:a="http://schemas.openxmlformats.org/drawingml/2006/main">
               <a:ext uri="{FF2B5EF4-FFF2-40B4-BE49-F238E27FC236}">
-                <a16:creationId xmlns:a16="http://schemas.microsoft.com/office/drawing/2014/main" id="{2D5CD8B4-ABDC-421E-B740-E2ADB244B911}"/>
+                <a16:creationId xmlns:a16="http://schemas.microsoft.com/office/drawing/2014/main" id="{5313BBD4-D502-4240-9818-68D05C7CA707}"/>
               </a:ext>
             </a:extLst>
           </p:cNvPr>
@@ -1849,7 +1849,7 @@
           <p:cNvPr id="3" name="Title">
             <a:extLst xmlns:a="http://schemas.openxmlformats.org/drawingml/2006/main">
               <a:ext uri="{FF2B5EF4-FFF2-40B4-BE49-F238E27FC236}">
-                <a16:creationId xmlns:a16="http://schemas.microsoft.com/office/drawing/2014/main" id="{D510CFBB-303F-41A5-B7EC-E24DA7221CE0}"/>
+                <a16:creationId xmlns:a16="http://schemas.microsoft.com/office/drawing/2014/main" id="{6C810890-2C9F-48E6-9057-A7B40EF840D4}"/>
               </a:ext>
             </a:extLst>
           </p:cNvPr>
@@ -2078,7 +2078,7 @@
           <p:cNvPr id="2" name="Body">
             <a:extLst xmlns:a="http://schemas.openxmlformats.org/drawingml/2006/main">
               <a:ext uri="{FF2B5EF4-FFF2-40B4-BE49-F238E27FC236}">
-                <a16:creationId xmlns:a16="http://schemas.microsoft.com/office/drawing/2014/main" id="{FD9FC2A2-D567-4F68-B68F-523E45F75F93}"/>
+                <a16:creationId xmlns:a16="http://schemas.microsoft.com/office/drawing/2014/main" id="{941BC682-882A-4414-8B98-8EB7CC4FC4E9}"/>
               </a:ext>
             </a:extLst>
           </p:cNvPr>
@@ -2324,7 +2324,7 @@
           <p:cNvPr id="4" name="Title">
             <a:extLst xmlns:a="http://schemas.openxmlformats.org/drawingml/2006/main">
               <a:ext uri="{FF2B5EF4-FFF2-40B4-BE49-F238E27FC236}">
-                <a16:creationId xmlns:a16="http://schemas.microsoft.com/office/drawing/2014/main" id="{FE3D01E7-5BD5-479D-9831-E4460A14EF5F}"/>
+                <a16:creationId xmlns:a16="http://schemas.microsoft.com/office/drawing/2014/main" id="{C217C1DF-632F-4D8A-839C-F9910F924324}"/>
               </a:ext>
             </a:extLst>
           </p:cNvPr>
@@ -2553,7 +2553,7 @@
           <p:cNvPr id="2" name="Left column">
             <a:extLst xmlns:a="http://schemas.openxmlformats.org/drawingml/2006/main">
               <a:ext uri="{FF2B5EF4-FFF2-40B4-BE49-F238E27FC236}">
-                <a16:creationId xmlns:a16="http://schemas.microsoft.com/office/drawing/2014/main" id="{70F6D983-9847-4811-A9F1-5EADFDFDB7B5}"/>
+                <a16:creationId xmlns:a16="http://schemas.microsoft.com/office/drawing/2014/main" id="{B30A596C-BE49-469D-ACD7-3CCBAF35AF84}"/>
               </a:ext>
             </a:extLst>
           </p:cNvPr>
@@ -2782,7 +2782,7 @@
           <p:cNvPr id="3" name="Right column">
             <a:extLst xmlns:a="http://schemas.openxmlformats.org/drawingml/2006/main">
               <a:ext uri="{FF2B5EF4-FFF2-40B4-BE49-F238E27FC236}">
-                <a16:creationId xmlns:a16="http://schemas.microsoft.com/office/drawing/2014/main" id="{61917D66-4F15-4853-80F7-B227346B7ACB}"/>
+                <a16:creationId xmlns:a16="http://schemas.microsoft.com/office/drawing/2014/main" id="{2A645635-7B13-4EE6-866E-83AE4A347A29}"/>
               </a:ext>
             </a:extLst>
           </p:cNvPr>
@@ -3028,7 +3028,7 @@
           <p:cNvPr id="3" name="Title">
             <a:extLst xmlns:a="http://schemas.openxmlformats.org/drawingml/2006/main">
               <a:ext uri="{FF2B5EF4-FFF2-40B4-BE49-F238E27FC236}">
-                <a16:creationId xmlns:a16="http://schemas.microsoft.com/office/drawing/2014/main" id="{61E448EC-16CD-45E7-8934-D6D6BD3FE457}"/>
+                <a16:creationId xmlns:a16="http://schemas.microsoft.com/office/drawing/2014/main" id="{3D9C0B9F-DD9C-4BFA-9055-7466028A2A09}"/>
               </a:ext>
             </a:extLst>
           </p:cNvPr>
@@ -3257,7 +3257,7 @@
           <p:cNvPr id="2" name="Left column">
             <a:extLst xmlns:a="http://schemas.openxmlformats.org/drawingml/2006/main">
               <a:ext uri="{FF2B5EF4-FFF2-40B4-BE49-F238E27FC236}">
-                <a16:creationId xmlns:a16="http://schemas.microsoft.com/office/drawing/2014/main" id="{DE7F7CFA-4CD0-4D54-BEBE-2A1F5A5F0E5D}"/>
+                <a16:creationId xmlns:a16="http://schemas.microsoft.com/office/drawing/2014/main" id="{85982821-E438-41C6-9BDA-77F0C77FCDD2}"/>
               </a:ext>
             </a:extLst>
           </p:cNvPr>
@@ -3524,12 +3524,12 @@
   </p:cSld>
   <p:clrMap bg1="lt1" tx1="dk1" bg2="lt2" tx2="dk2" accent1="accent1" accent2="accent2" accent3="accent3" accent4="accent4" accent5="accent5" accent6="accent6" hlink="hlink" folHlink="folHlink"/>
   <p:sldLayoutIdLst>
-    <p:sldLayoutId xmlns:r="http://schemas.openxmlformats.org/officeDocument/2006/relationships" id="2147483649" r:id="R48b563e9867d4a46"/>
-    <p:sldLayoutId xmlns:r="http://schemas.openxmlformats.org/officeDocument/2006/relationships" id="2147483650" r:id="Rd1ca58ca82c2488c"/>
-    <p:sldLayoutId xmlns:r="http://schemas.openxmlformats.org/officeDocument/2006/relationships" id="2147483651" r:id="Rc5fa248ae21d4705"/>
-    <p:sldLayoutId xmlns:r="http://schemas.openxmlformats.org/officeDocument/2006/relationships" id="2147483652" r:id="Re786347c895c4679"/>
-    <p:sldLayoutId xmlns:r="http://schemas.openxmlformats.org/officeDocument/2006/relationships" id="2147483653" r:id="R2c71bb20d78640d0"/>
-    <p:sldLayoutId xmlns:r="http://schemas.openxmlformats.org/officeDocument/2006/relationships" id="2147483654" r:id="R4e9d9617be2947c4"/>
+    <p:sldLayoutId xmlns:r="http://schemas.openxmlformats.org/officeDocument/2006/relationships" id="2147483649" r:id="Rfba1b64c03fb495a"/>
+    <p:sldLayoutId xmlns:r="http://schemas.openxmlformats.org/officeDocument/2006/relationships" id="2147483650" r:id="R5518fe36669e46cf"/>
+    <p:sldLayoutId xmlns:r="http://schemas.openxmlformats.org/officeDocument/2006/relationships" id="2147483651" r:id="Ra273338bfe754aaa"/>
+    <p:sldLayoutId xmlns:r="http://schemas.openxmlformats.org/officeDocument/2006/relationships" id="2147483652" r:id="R9df3b946c33041be"/>
+    <p:sldLayoutId xmlns:r="http://schemas.openxmlformats.org/officeDocument/2006/relationships" id="2147483653" r:id="Rcad79bbd7cbc4c09"/>
+    <p:sldLayoutId xmlns:r="http://schemas.openxmlformats.org/officeDocument/2006/relationships" id="2147483654" r:id="Rd34c27103c6b4596"/>
   </p:sldLayoutIdLst>
   <p:txStyles>
     <p:titleStyle>
@@ -4080,7 +4080,7 @@
           <p:cNvPr id="8" name="">
             <a:extLst xmlns:a="http://schemas.openxmlformats.org/drawingml/2006/main">
               <a:ext uri="{FF2B5EF4-FFF2-40B4-BE49-F238E27FC236}">
-                <a16:creationId xmlns:a16="http://schemas.microsoft.com/office/drawing/2014/main" id="{64CEFD06-B4B7-4FF4-BC34-E636113C0CB3}"/>
+                <a16:creationId xmlns:a16="http://schemas.microsoft.com/office/drawing/2014/main" id="{96F612AA-7781-4392-A0A9-B0B0C7E2CA19}"/>
               </a:ext>
             </a:extLst>
           </p:cNvPr>
@@ -4238,7 +4238,7 @@
           <p:cNvPr id="2" name="">
             <a:extLst xmlns:a="http://schemas.openxmlformats.org/drawingml/2006/main">
               <a:ext uri="{FF2B5EF4-FFF2-40B4-BE49-F238E27FC236}">
-                <a16:creationId xmlns:a16="http://schemas.microsoft.com/office/drawing/2014/main" id="{A7FE380A-1FE5-4628-8268-511D86CA8796}"/>
+                <a16:creationId xmlns:a16="http://schemas.microsoft.com/office/drawing/2014/main" id="{1DCECDA1-EE98-43C3-BBE6-E6C798ABC146}"/>
               </a:ext>
             </a:extLst>
           </p:cNvPr>
@@ -4396,7 +4396,7 @@
           <p:cNvPr id="3" name="">
             <a:extLst xmlns:a="http://schemas.openxmlformats.org/drawingml/2006/main">
               <a:ext uri="{FF2B5EF4-FFF2-40B4-BE49-F238E27FC236}">
-                <a16:creationId xmlns:a16="http://schemas.microsoft.com/office/drawing/2014/main" id="{08CF8D6F-BEEE-486A-9701-BE1368157608}"/>
+                <a16:creationId xmlns:a16="http://schemas.microsoft.com/office/drawing/2014/main" id="{9E2A1D23-5D0F-45B1-913B-C619D6E04279}"/>
               </a:ext>
             </a:extLst>
           </p:cNvPr>
@@ -4406,7 +4406,7 @@
           <p:nvPr/>
         </p:nvPicPr>
         <p:blipFill>
-          <a:blip xmlns:r="http://schemas.openxmlformats.org/officeDocument/2006/relationships" xmlns:a="http://schemas.openxmlformats.org/drawingml/2006/main" r:embed="R944b425164cf42a9"/>
+          <a:blip xmlns:r="http://schemas.openxmlformats.org/officeDocument/2006/relationships" xmlns:a="http://schemas.openxmlformats.org/drawingml/2006/main" r:embed="R3c18aa23c2404adc"/>
           <a:srcRect xmlns:a="http://schemas.openxmlformats.org/drawingml/2006/main" l="25926" t="0" r="25926" b="0"/>
           <a:stretch xmlns:a="http://schemas.openxmlformats.org/drawingml/2006/main">
             <a:fillRect l="0" t="0" r="0" b="0"/>
@@ -4427,7 +4427,7 @@
           <p:cNvPr id="4" name="">
             <a:extLst xmlns:a="http://schemas.openxmlformats.org/drawingml/2006/main">
               <a:ext uri="{FF2B5EF4-FFF2-40B4-BE49-F238E27FC236}">
-                <a16:creationId xmlns:a16="http://schemas.microsoft.com/office/drawing/2014/main" id="{85A01C8F-35A7-4D00-8785-6445851D31DC}"/>
+                <a16:creationId xmlns:a16="http://schemas.microsoft.com/office/drawing/2014/main" id="{7691D2F2-5F1B-45AF-8B03-2279CBC191B0}"/>
               </a:ext>
             </a:extLst>
           </p:cNvPr>
@@ -4585,7 +4585,7 @@
           <p:cNvPr id="5" name="">
             <a:extLst xmlns:a="http://schemas.openxmlformats.org/drawingml/2006/main">
               <a:ext uri="{FF2B5EF4-FFF2-40B4-BE49-F238E27FC236}">
-                <a16:creationId xmlns:a16="http://schemas.microsoft.com/office/drawing/2014/main" id="{4A1FE850-305A-4D86-9788-5946322EB4B1}"/>
+                <a16:creationId xmlns:a16="http://schemas.microsoft.com/office/drawing/2014/main" id="{4F08C3D8-79DA-4926-888B-EC6CEC09882B}"/>
               </a:ext>
             </a:extLst>
           </p:cNvPr>
@@ -4789,7 +4789,7 @@
           <p:cNvPr id="6" name="">
             <a:extLst xmlns:a="http://schemas.openxmlformats.org/drawingml/2006/main">
               <a:ext uri="{FF2B5EF4-FFF2-40B4-BE49-F238E27FC236}">
-                <a16:creationId xmlns:a16="http://schemas.microsoft.com/office/drawing/2014/main" id="{4B7811BD-256F-47AC-BC9A-D98FB8CFB3C8}"/>
+                <a16:creationId xmlns:a16="http://schemas.microsoft.com/office/drawing/2014/main" id="{EF708CB4-F4B3-4282-B8CE-70BA262946B3}"/>
               </a:ext>
             </a:extLst>
           </p:cNvPr>
@@ -4947,7 +4947,7 @@
           <p:cNvPr id="7" name="">
             <a:extLst xmlns:a="http://schemas.openxmlformats.org/drawingml/2006/main">
               <a:ext uri="{FF2B5EF4-FFF2-40B4-BE49-F238E27FC236}">
-                <a16:creationId xmlns:a16="http://schemas.microsoft.com/office/drawing/2014/main" id="{3093CC46-8B87-4E4C-B36C-126F49EEED27}"/>
+                <a16:creationId xmlns:a16="http://schemas.microsoft.com/office/drawing/2014/main" id="{6A9F2821-B487-47F8-9D28-2C322DCC5DF5}"/>
               </a:ext>
             </a:extLst>
           </p:cNvPr>
@@ -5103,7 +5103,7 @@
     </p:spTree>
     <p:extLst>
       <p:ext uri="{BB962C8B-B14F-4D97-AF65-F5344CB8AC3E}">
-        <p14:creationId xmlns:p14="http://schemas.microsoft.com/office/powerpoint/2010/main" val="545162163"/>
+        <p14:creationId xmlns:p14="http://schemas.microsoft.com/office/powerpoint/2010/main" val="370430726"/>
       </p:ext>
     </p:extLst>
   </p:cSld>
@@ -5134,7 +5134,7 @@
           <p:cNvPr id="8" name="">
             <a:extLst xmlns:a="http://schemas.openxmlformats.org/drawingml/2006/main">
               <a:ext uri="{FF2B5EF4-FFF2-40B4-BE49-F238E27FC236}">
-                <a16:creationId xmlns:a16="http://schemas.microsoft.com/office/drawing/2014/main" id="{3BB8DE61-579A-4C64-8C2A-AD0E05224F04}"/>
+                <a16:creationId xmlns:a16="http://schemas.microsoft.com/office/drawing/2014/main" id="{2CB30907-AE43-46A9-905E-6F955EC39430}"/>
               </a:ext>
             </a:extLst>
           </p:cNvPr>
@@ -5292,7 +5292,7 @@
           <p:cNvPr id="2" name="">
             <a:extLst xmlns:a="http://schemas.openxmlformats.org/drawingml/2006/main">
               <a:ext uri="{FF2B5EF4-FFF2-40B4-BE49-F238E27FC236}">
-                <a16:creationId xmlns:a16="http://schemas.microsoft.com/office/drawing/2014/main" id="{5A4A1D57-ACB7-44D3-A745-E938099C52C0}"/>
+                <a16:creationId xmlns:a16="http://schemas.microsoft.com/office/drawing/2014/main" id="{C3FEC54E-B3CF-4C31-99F2-254ACFA44C99}"/>
               </a:ext>
             </a:extLst>
           </p:cNvPr>
@@ -5450,7 +5450,7 @@
           <p:cNvPr id="3" name="">
             <a:extLst xmlns:a="http://schemas.openxmlformats.org/drawingml/2006/main">
               <a:ext uri="{FF2B5EF4-FFF2-40B4-BE49-F238E27FC236}">
-                <a16:creationId xmlns:a16="http://schemas.microsoft.com/office/drawing/2014/main" id="{0CC4F5DB-4194-4C55-9D3E-890A5E903FEB}"/>
+                <a16:creationId xmlns:a16="http://schemas.microsoft.com/office/drawing/2014/main" id="{98E46B0A-CF0F-4854-BEB1-657803FC7A3E}"/>
               </a:ext>
             </a:extLst>
           </p:cNvPr>
@@ -5608,7 +5608,7 @@
           <p:cNvPr id="4" name="">
             <a:extLst xmlns:a="http://schemas.openxmlformats.org/drawingml/2006/main">
               <a:ext uri="{FF2B5EF4-FFF2-40B4-BE49-F238E27FC236}">
-                <a16:creationId xmlns:a16="http://schemas.microsoft.com/office/drawing/2014/main" id="{E86007BE-8AFA-4C15-AA96-54660CEFFBD3}"/>
+                <a16:creationId xmlns:a16="http://schemas.microsoft.com/office/drawing/2014/main" id="{F36614AA-F35B-416B-8A1F-6903D01CD48B}"/>
               </a:ext>
             </a:extLst>
           </p:cNvPr>
@@ -5789,7 +5789,7 @@
           <p:cNvPr id="5" name="">
             <a:extLst xmlns:a="http://schemas.openxmlformats.org/drawingml/2006/main">
               <a:ext uri="{FF2B5EF4-FFF2-40B4-BE49-F238E27FC236}">
-                <a16:creationId xmlns:a16="http://schemas.microsoft.com/office/drawing/2014/main" id="{A7741810-ACD1-4D77-9FC1-58AB1379CA53}"/>
+                <a16:creationId xmlns:a16="http://schemas.microsoft.com/office/drawing/2014/main" id="{30C8651E-4A9B-449F-8FD1-DE64C83F613D}"/>
               </a:ext>
             </a:extLst>
           </p:cNvPr>
@@ -5970,7 +5970,7 @@
           <p:cNvPr id="6" name="">
             <a:extLst xmlns:a="http://schemas.openxmlformats.org/drawingml/2006/main">
               <a:ext uri="{FF2B5EF4-FFF2-40B4-BE49-F238E27FC236}">
-                <a16:creationId xmlns:a16="http://schemas.microsoft.com/office/drawing/2014/main" id="{A36C561D-E888-4CF2-9BB0-F5394741F5C6}"/>
+                <a16:creationId xmlns:a16="http://schemas.microsoft.com/office/drawing/2014/main" id="{3FB21EA9-1B1C-4977-9BD1-FA41F954B4A1}"/>
               </a:ext>
             </a:extLst>
           </p:cNvPr>
@@ -6128,7 +6128,7 @@
           <p:cNvPr id="7" name="">
             <a:extLst xmlns:a="http://schemas.openxmlformats.org/drawingml/2006/main">
               <a:ext uri="{FF2B5EF4-FFF2-40B4-BE49-F238E27FC236}">
-                <a16:creationId xmlns:a16="http://schemas.microsoft.com/office/drawing/2014/main" id="{C47764D3-49EB-4F18-B8EB-AC8B2D419E63}"/>
+                <a16:creationId xmlns:a16="http://schemas.microsoft.com/office/drawing/2014/main" id="{643DF093-EBB1-4DC5-BFEE-DA1D7E20CD2D}"/>
               </a:ext>
             </a:extLst>
           </p:cNvPr>
@@ -6275,7 +6275,7 @@
                 <a:latin typeface="Arial"/>
                 <a:ea typeface="Arial"/>
                 <a:cs typeface="Arial"/>
-                <a:hlinkClick xmlns:r="http://schemas.openxmlformats.org/officeDocument/2006/relationships" r:id="R3d86a74a2ffd44e4"/>
+                <a:hlinkClick xmlns:r="http://schemas.openxmlformats.org/officeDocument/2006/relationships" r:id="R8be700cf918f4d9c"/>
               </a:rPr>
               <a:t>chargeneighbour-theta.vercel.app/support</a:t>
             </a:r>
@@ -6285,7 +6285,7 @@
     </p:spTree>
     <p:extLst>
       <p:ext uri="{BB962C8B-B14F-4D97-AF65-F5344CB8AC3E}">
-        <p14:creationId xmlns:p14="http://schemas.microsoft.com/office/powerpoint/2010/main" val="1182824212"/>
+        <p14:creationId xmlns:p14="http://schemas.microsoft.com/office/powerpoint/2010/main" val="29761095"/>
       </p:ext>
     </p:extLst>
   </p:cSld>
@@ -6316,7 +6316,7 @@
           <p:cNvPr id="11" name="">
             <a:extLst xmlns:a="http://schemas.openxmlformats.org/drawingml/2006/main">
               <a:ext uri="{FF2B5EF4-FFF2-40B4-BE49-F238E27FC236}">
-                <a16:creationId xmlns:a16="http://schemas.microsoft.com/office/drawing/2014/main" id="{FF9C0E40-927D-44F0-8E38-334FA0CB05EB}"/>
+                <a16:creationId xmlns:a16="http://schemas.microsoft.com/office/drawing/2014/main" id="{D847A788-3D1D-4517-8901-8938A7985212}"/>
               </a:ext>
             </a:extLst>
           </p:cNvPr>
@@ -6474,7 +6474,7 @@
           <p:cNvPr id="2" name="">
             <a:extLst xmlns:a="http://schemas.openxmlformats.org/drawingml/2006/main">
               <a:ext uri="{FF2B5EF4-FFF2-40B4-BE49-F238E27FC236}">
-                <a16:creationId xmlns:a16="http://schemas.microsoft.com/office/drawing/2014/main" id="{7DA0B7CC-20B9-460B-8708-E1CEEADE384E}"/>
+                <a16:creationId xmlns:a16="http://schemas.microsoft.com/office/drawing/2014/main" id="{8F0796C7-D0D8-4B63-8F68-99BB9DA5C1E9}"/>
               </a:ext>
             </a:extLst>
           </p:cNvPr>
@@ -6632,7 +6632,7 @@
           <p:cNvPr id="3" name="">
             <a:extLst xmlns:a="http://schemas.openxmlformats.org/drawingml/2006/main">
               <a:ext uri="{FF2B5EF4-FFF2-40B4-BE49-F238E27FC236}">
-                <a16:creationId xmlns:a16="http://schemas.microsoft.com/office/drawing/2014/main" id="{015B57CC-AC14-4E71-B2A0-C456F091BC44}"/>
+                <a16:creationId xmlns:a16="http://schemas.microsoft.com/office/drawing/2014/main" id="{E04CDD0C-7137-4EEA-9DBA-4D54930241EE}"/>
               </a:ext>
             </a:extLst>
           </p:cNvPr>
@@ -6790,7 +6790,7 @@
           <p:cNvPr id="4" name="">
             <a:extLst xmlns:a="http://schemas.openxmlformats.org/drawingml/2006/main">
               <a:ext uri="{FF2B5EF4-FFF2-40B4-BE49-F238E27FC236}">
-                <a16:creationId xmlns:a16="http://schemas.microsoft.com/office/drawing/2014/main" id="{520754CD-87FA-4E6C-BD92-04410C3991D2}"/>
+                <a16:creationId xmlns:a16="http://schemas.microsoft.com/office/drawing/2014/main" id="{C93D2469-F07C-437D-B0A0-1F2685358426}"/>
               </a:ext>
             </a:extLst>
           </p:cNvPr>
@@ -6971,7 +6971,7 @@
           <p:cNvPr id="5" name="">
             <a:extLst xmlns:a="http://schemas.openxmlformats.org/drawingml/2006/main">
               <a:ext uri="{FF2B5EF4-FFF2-40B4-BE49-F238E27FC236}">
-                <a16:creationId xmlns:a16="http://schemas.microsoft.com/office/drawing/2014/main" id="{BB1CA4D4-A05D-42BB-BD94-345B3A2B6043}"/>
+                <a16:creationId xmlns:a16="http://schemas.microsoft.com/office/drawing/2014/main" id="{76531137-83AF-4EAC-897C-46F622AC3306}"/>
               </a:ext>
             </a:extLst>
           </p:cNvPr>
@@ -7129,7 +7129,7 @@
           <p:cNvPr id="6" name="">
             <a:extLst xmlns:a="http://schemas.openxmlformats.org/drawingml/2006/main">
               <a:ext uri="{FF2B5EF4-FFF2-40B4-BE49-F238E27FC236}">
-                <a16:creationId xmlns:a16="http://schemas.microsoft.com/office/drawing/2014/main" id="{AE80CC5B-1B70-4636-B177-6FBD33600582}"/>
+                <a16:creationId xmlns:a16="http://schemas.microsoft.com/office/drawing/2014/main" id="{7BD9A60F-E602-4326-81BF-0664B5C030CB}"/>
               </a:ext>
             </a:extLst>
           </p:cNvPr>
@@ -7287,7 +7287,7 @@
           <p:cNvPr id="7" name="">
             <a:extLst xmlns:a="http://schemas.openxmlformats.org/drawingml/2006/main">
               <a:ext uri="{FF2B5EF4-FFF2-40B4-BE49-F238E27FC236}">
-                <a16:creationId xmlns:a16="http://schemas.microsoft.com/office/drawing/2014/main" id="{50E95087-BAB2-4F84-A584-87EB0876C80A}"/>
+                <a16:creationId xmlns:a16="http://schemas.microsoft.com/office/drawing/2014/main" id="{3F845D3A-5C6C-4CE7-9468-7B50CC5C5D51}"/>
               </a:ext>
             </a:extLst>
           </p:cNvPr>
@@ -7445,7 +7445,7 @@
           <p:cNvPr id="8" name="">
             <a:extLst xmlns:a="http://schemas.openxmlformats.org/drawingml/2006/main">
               <a:ext uri="{FF2B5EF4-FFF2-40B4-BE49-F238E27FC236}">
-                <a16:creationId xmlns:a16="http://schemas.microsoft.com/office/drawing/2014/main" id="{D2E40E07-67FE-47FB-B6DC-97AA45222EEE}"/>
+                <a16:creationId xmlns:a16="http://schemas.microsoft.com/office/drawing/2014/main" id="{C8BD4F85-CE4F-4786-ACAD-DB62AF85A558}"/>
               </a:ext>
             </a:extLst>
           </p:cNvPr>
@@ -7603,7 +7603,7 @@
           <p:cNvPr id="9" name="">
             <a:extLst xmlns:a="http://schemas.openxmlformats.org/drawingml/2006/main">
               <a:ext uri="{FF2B5EF4-FFF2-40B4-BE49-F238E27FC236}">
-                <a16:creationId xmlns:a16="http://schemas.microsoft.com/office/drawing/2014/main" id="{E8FC14DE-B4E6-4BD3-B171-E7EDEEAC40CE}"/>
+                <a16:creationId xmlns:a16="http://schemas.microsoft.com/office/drawing/2014/main" id="{D6304FA9-3736-4149-A224-5A6DE4E43A76}"/>
               </a:ext>
             </a:extLst>
           </p:cNvPr>
@@ -7761,7 +7761,7 @@
           <p:cNvPr id="10" name="">
             <a:extLst xmlns:a="http://schemas.openxmlformats.org/drawingml/2006/main">
               <a:ext uri="{FF2B5EF4-FFF2-40B4-BE49-F238E27FC236}">
-                <a16:creationId xmlns:a16="http://schemas.microsoft.com/office/drawing/2014/main" id="{1D87A661-87AA-4756-82D7-481DCCBB241F}"/>
+                <a16:creationId xmlns:a16="http://schemas.microsoft.com/office/drawing/2014/main" id="{92578C59-EA1D-4505-BB95-F34524B70154}"/>
               </a:ext>
             </a:extLst>
           </p:cNvPr>
@@ -7917,7 +7917,7 @@
     </p:spTree>
     <p:extLst>
       <p:ext uri="{BB962C8B-B14F-4D97-AF65-F5344CB8AC3E}">
-        <p14:creationId xmlns:p14="http://schemas.microsoft.com/office/powerpoint/2010/main" val="1666850979"/>
+        <p14:creationId xmlns:p14="http://schemas.microsoft.com/office/powerpoint/2010/main" val="2048408092"/>
       </p:ext>
     </p:extLst>
   </p:cSld>
@@ -7948,7 +7948,7 @@
           <p:cNvPr id="13" name="">
             <a:extLst xmlns:a="http://schemas.openxmlformats.org/drawingml/2006/main">
               <a:ext uri="{FF2B5EF4-FFF2-40B4-BE49-F238E27FC236}">
-                <a16:creationId xmlns:a16="http://schemas.microsoft.com/office/drawing/2014/main" id="{525BB548-066C-4B4B-94C8-0D65404043B5}"/>
+                <a16:creationId xmlns:a16="http://schemas.microsoft.com/office/drawing/2014/main" id="{F774B23D-2C88-40BA-A190-DBEA3460463C}"/>
               </a:ext>
             </a:extLst>
           </p:cNvPr>
@@ -8096,7 +8096,7 @@
                 <a:ea typeface="Arial"/>
                 <a:cs typeface="Arial"/>
               </a:rPr>
-              <a:t>The product journey</a:t>
+              <a:t>The mobile driver journey</a:t>
             </a:r>
           </a:p>
         </p:txBody>
@@ -8106,7 +8106,7 @@
           <p:cNvPr id="2" name="">
             <a:extLst xmlns:a="http://schemas.openxmlformats.org/drawingml/2006/main">
               <a:ext uri="{FF2B5EF4-FFF2-40B4-BE49-F238E27FC236}">
-                <a16:creationId xmlns:a16="http://schemas.microsoft.com/office/drawing/2014/main" id="{BB2A33E3-CE0A-4395-9B7B-33EE43658819}"/>
+                <a16:creationId xmlns:a16="http://schemas.microsoft.com/office/drawing/2014/main" id="{C28FFA35-17CF-4B30-95B7-3F7513981D74}"/>
               </a:ext>
             </a:extLst>
           </p:cNvPr>
@@ -8264,7 +8264,7 @@
           <p:cNvPr id="3" name="">
             <a:extLst xmlns:a="http://schemas.openxmlformats.org/drawingml/2006/main">
               <a:ext uri="{FF2B5EF4-FFF2-40B4-BE49-F238E27FC236}">
-                <a16:creationId xmlns:a16="http://schemas.microsoft.com/office/drawing/2014/main" id="{13815A00-3408-4EC0-8140-987F4558B118}"/>
+                <a16:creationId xmlns:a16="http://schemas.microsoft.com/office/drawing/2014/main" id="{E75173A7-9D14-435B-BEA5-B013C86A293F}"/>
               </a:ext>
             </a:extLst>
           </p:cNvPr>
@@ -8422,7 +8422,7 @@
           <p:cNvPr id="4" name="">
             <a:extLst xmlns:a="http://schemas.openxmlformats.org/drawingml/2006/main">
               <a:ext uri="{FF2B5EF4-FFF2-40B4-BE49-F238E27FC236}">
-                <a16:creationId xmlns:a16="http://schemas.microsoft.com/office/drawing/2014/main" id="{F0D3807C-96B3-4A65-A56A-E0C4F9FF1F4E}"/>
+                <a16:creationId xmlns:a16="http://schemas.microsoft.com/office/drawing/2014/main" id="{9069F66F-F77B-443F-A292-FFC194B3E659}"/>
               </a:ext>
             </a:extLst>
           </p:cNvPr>
@@ -8570,7 +8570,7 @@
                 <a:ea typeface="Arial"/>
                 <a:cs typeface="Arial"/>
               </a:rPr>
-              <a:t>Discover public stations</a:t>
+              <a:t>Search immediately</a:t>
             </a:r>
           </a:p>
         </p:txBody>
@@ -8580,7 +8580,7 @@
           <p:cNvPr id="5" name="">
             <a:extLst xmlns:a="http://schemas.openxmlformats.org/drawingml/2006/main">
               <a:ext uri="{FF2B5EF4-FFF2-40B4-BE49-F238E27FC236}">
-                <a16:creationId xmlns:a16="http://schemas.microsoft.com/office/drawing/2014/main" id="{BF867AB1-D79D-445D-82EE-280F0A5457D1}"/>
+                <a16:creationId xmlns:a16="http://schemas.microsoft.com/office/drawing/2014/main" id="{315108BF-1BE4-4898-B179-0DBA07C65D6D}"/>
               </a:ext>
             </a:extLst>
           </p:cNvPr>
@@ -8728,7 +8728,7 @@
                 <a:ea typeface="Arial"/>
                 <a:cs typeface="Arial"/>
               </a:rPr>
-              <a:t>Explore real Google Maps places and driving directions.</a:t>
+              <a:t>Enter a destination or choose optional GPS for nearby places.</a:t>
             </a:r>
           </a:p>
         </p:txBody>
@@ -8738,7 +8738,7 @@
           <p:cNvPr id="6" name="">
             <a:extLst xmlns:a="http://schemas.openxmlformats.org/drawingml/2006/main">
               <a:ext uri="{FF2B5EF4-FFF2-40B4-BE49-F238E27FC236}">
-                <a16:creationId xmlns:a16="http://schemas.microsoft.com/office/drawing/2014/main" id="{BFD650E7-35F6-4027-B041-83A14822D0A2}"/>
+                <a16:creationId xmlns:a16="http://schemas.microsoft.com/office/drawing/2014/main" id="{785A0EB4-F200-440F-99DB-64E79FB667C1}"/>
               </a:ext>
             </a:extLst>
           </p:cNvPr>
@@ -8886,7 +8886,7 @@
                 <a:ea typeface="Arial"/>
                 <a:cs typeface="Arial"/>
               </a:rPr>
-              <a:t>Apply to share a charger</a:t>
+              <a:t>Check compatibility</a:t>
             </a:r>
           </a:p>
         </p:txBody>
@@ -8896,7 +8896,7 @@
           <p:cNvPr id="7" name="">
             <a:extLst xmlns:a="http://schemas.openxmlformats.org/drawingml/2006/main">
               <a:ext uri="{FF2B5EF4-FFF2-40B4-BE49-F238E27FC236}">
-                <a16:creationId xmlns:a16="http://schemas.microsoft.com/office/drawing/2014/main" id="{84642CC4-739A-4446-ABFA-793AE44CB57D}"/>
+                <a16:creationId xmlns:a16="http://schemas.microsoft.com/office/drawing/2014/main" id="{D6F5A98A-2195-48D6-B955-795FACA0A76F}"/>
               </a:ext>
             </a:extLst>
           </p:cNvPr>
@@ -9044,7 +9044,7 @@
                 <a:ea typeface="Arial"/>
                 <a:cs typeface="Arial"/>
               </a:rPr>
-              <a:t>Owners submit an application for access and equipment review.</a:t>
+              <a:t>Separate supplied connector information from unknown specifications.</a:t>
             </a:r>
           </a:p>
         </p:txBody>
@@ -9054,7 +9054,7 @@
           <p:cNvPr id="8" name="">
             <a:extLst xmlns:a="http://schemas.openxmlformats.org/drawingml/2006/main">
               <a:ext uri="{FF2B5EF4-FFF2-40B4-BE49-F238E27FC236}">
-                <a16:creationId xmlns:a16="http://schemas.microsoft.com/office/drawing/2014/main" id="{15DC7600-9326-49EF-B503-DDA35A72A718}"/>
+                <a16:creationId xmlns:a16="http://schemas.microsoft.com/office/drawing/2014/main" id="{B2B7E834-DC13-4F85-AD47-56F784B954F2}"/>
               </a:ext>
             </a:extLst>
           </p:cNvPr>
@@ -9202,7 +9202,7 @@
                 <a:ea typeface="Arial"/>
                 <a:cs typeface="Arial"/>
               </a:rPr>
-              <a:t>Offer a planned local stop</a:t>
+              <a:t>Explore the stop</a:t>
             </a:r>
           </a:p>
         </p:txBody>
@@ -9212,7 +9212,7 @@
           <p:cNvPr id="9" name="">
             <a:extLst xmlns:a="http://schemas.openxmlformats.org/drawingml/2006/main">
               <a:ext uri="{FF2B5EF4-FFF2-40B4-BE49-F238E27FC236}">
-                <a16:creationId xmlns:a16="http://schemas.microsoft.com/office/drawing/2014/main" id="{D8F8053E-3496-408F-904F-41FADF917633}"/>
+                <a16:creationId xmlns:a16="http://schemas.microsoft.com/office/drawing/2014/main" id="{89E4CF8C-0C35-4734-84E4-FD3001156258}"/>
               </a:ext>
             </a:extLst>
           </p:cNvPr>
@@ -9360,7 +9360,7 @@
                 <a:ea typeface="Arial"/>
                 <a:cs typeface="Arial"/>
               </a:rPr>
-              <a:t>Approved hosts publish offered hours for compatible drivers.</a:t>
+              <a:t>Inspect station details. The sample gallery labels its AI images and reviews.</a:t>
             </a:r>
           </a:p>
         </p:txBody>
@@ -9370,7 +9370,7 @@
           <p:cNvPr id="10" name="">
             <a:extLst xmlns:a="http://schemas.openxmlformats.org/drawingml/2006/main">
               <a:ext uri="{FF2B5EF4-FFF2-40B4-BE49-F238E27FC236}">
-                <a16:creationId xmlns:a16="http://schemas.microsoft.com/office/drawing/2014/main" id="{8B7F3B1B-7DC9-4FAC-9C42-AD01337729CC}"/>
+                <a16:creationId xmlns:a16="http://schemas.microsoft.com/office/drawing/2014/main" id="{D26C108D-C8B6-487A-A0FB-9446AD84984D}"/>
               </a:ext>
             </a:extLst>
           </p:cNvPr>
@@ -9518,7 +9518,7 @@
                 <a:ea typeface="Arial"/>
                 <a:cs typeface="Arial"/>
               </a:rPr>
-              <a:t>Record the session</a:t>
+              <a:t>Preview the road route</a:t>
             </a:r>
           </a:p>
         </p:txBody>
@@ -9528,7 +9528,7 @@
           <p:cNvPr id="11" name="">
             <a:extLst xmlns:a="http://schemas.openxmlformats.org/drawingml/2006/main">
               <a:ext uri="{FF2B5EF4-FFF2-40B4-BE49-F238E27FC236}">
-                <a16:creationId xmlns:a16="http://schemas.microsoft.com/office/drawing/2014/main" id="{FCB25BE1-5B78-454E-A469-D6D684D71F81}"/>
+                <a16:creationId xmlns:a16="http://schemas.microsoft.com/office/drawing/2014/main" id="{A34A2FE1-AE68-4D47-8CCB-FE9125F93D62}"/>
               </a:ext>
             </a:extLst>
           </p:cNvPr>
@@ -9676,7 +9676,7 @@
                 <a:ea typeface="Arial"/>
                 <a:cs typeface="Arial"/>
               </a:rPr>
-              <a:t>The proposed service uses confirmation and measured energy.</a:t>
+              <a:t>See a road line, driving distance and estimated time inside the website.</a:t>
             </a:r>
           </a:p>
         </p:txBody>
@@ -9686,7 +9686,7 @@
           <p:cNvPr id="12" name="">
             <a:extLst xmlns:a="http://schemas.openxmlformats.org/drawingml/2006/main">
               <a:ext uri="{FF2B5EF4-FFF2-40B4-BE49-F238E27FC236}">
-                <a16:creationId xmlns:a16="http://schemas.microsoft.com/office/drawing/2014/main" id="{1048CB62-21E8-484E-8B19-86ED283076EB}"/>
+                <a16:creationId xmlns:a16="http://schemas.microsoft.com/office/drawing/2014/main" id="{8EB1ABEE-8994-47F1-8F58-C8FE592899E4}"/>
               </a:ext>
             </a:extLst>
           </p:cNvPr>
@@ -9834,7 +9834,7 @@
                 <a:ea typeface="Arial"/>
                 <a:cs typeface="Arial"/>
               </a:rPr>
-              <a:t>Public discovery and host applications are separate from commercial activation.</a:t>
+              <a:t>Public discovery and demo samples stay separate from approved host bookings.</a:t>
             </a:r>
           </a:p>
         </p:txBody>
@@ -9842,7 +9842,7 @@
     </p:spTree>
     <p:extLst>
       <p:ext uri="{BB962C8B-B14F-4D97-AF65-F5344CB8AC3E}">
-        <p14:creationId xmlns:p14="http://schemas.microsoft.com/office/powerpoint/2010/main" val="569245637"/>
+        <p14:creationId xmlns:p14="http://schemas.microsoft.com/office/powerpoint/2010/main" val="1506509674"/>
       </p:ext>
     </p:extLst>
   </p:cSld>
@@ -9873,7 +9873,7 @@
           <p:cNvPr id="9" name="">
             <a:extLst xmlns:a="http://schemas.openxmlformats.org/drawingml/2006/main">
               <a:ext uri="{FF2B5EF4-FFF2-40B4-BE49-F238E27FC236}">
-                <a16:creationId xmlns:a16="http://schemas.microsoft.com/office/drawing/2014/main" id="{B1895169-954F-471D-83CE-B5EA54F4E17E}"/>
+                <a16:creationId xmlns:a16="http://schemas.microsoft.com/office/drawing/2014/main" id="{059DDAE0-414E-4424-AD5A-6E3C001E8FBD}"/>
               </a:ext>
             </a:extLst>
           </p:cNvPr>
@@ -10031,7 +10031,7 @@
           <p:cNvPr id="2" name="">
             <a:extLst xmlns:a="http://schemas.openxmlformats.org/drawingml/2006/main">
               <a:ext uri="{FF2B5EF4-FFF2-40B4-BE49-F238E27FC236}">
-                <a16:creationId xmlns:a16="http://schemas.microsoft.com/office/drawing/2014/main" id="{90897632-97A1-4696-B79E-C26FB0D25918}"/>
+                <a16:creationId xmlns:a16="http://schemas.microsoft.com/office/drawing/2014/main" id="{7BF432E5-7944-4A13-A618-BFD76749EA0C}"/>
               </a:ext>
             </a:extLst>
           </p:cNvPr>
@@ -10189,7 +10189,7 @@
           <p:cNvPr id="3" name="">
             <a:extLst xmlns:a="http://schemas.openxmlformats.org/drawingml/2006/main">
               <a:ext uri="{FF2B5EF4-FFF2-40B4-BE49-F238E27FC236}">
-                <a16:creationId xmlns:a16="http://schemas.microsoft.com/office/drawing/2014/main" id="{2C8D0770-10D2-421D-9D12-10EF98D4CC44}"/>
+                <a16:creationId xmlns:a16="http://schemas.microsoft.com/office/drawing/2014/main" id="{8BD31446-3540-49FB-8C71-34FE36D4E217}"/>
               </a:ext>
             </a:extLst>
           </p:cNvPr>
@@ -10347,7 +10347,7 @@
           <p:cNvPr id="4" name="">
             <a:extLst xmlns:a="http://schemas.openxmlformats.org/drawingml/2006/main">
               <a:ext uri="{FF2B5EF4-FFF2-40B4-BE49-F238E27FC236}">
-                <a16:creationId xmlns:a16="http://schemas.microsoft.com/office/drawing/2014/main" id="{CC9A8720-2A2C-4251-8A73-1DEAD39C0E58}"/>
+                <a16:creationId xmlns:a16="http://schemas.microsoft.com/office/drawing/2014/main" id="{3CEEA6C9-E376-4B92-BB16-1681CAEEC9A1}"/>
               </a:ext>
             </a:extLst>
           </p:cNvPr>
@@ -10505,7 +10505,7 @@
           <p:cNvPr id="5" name="">
             <a:extLst xmlns:a="http://schemas.openxmlformats.org/drawingml/2006/main">
               <a:ext uri="{FF2B5EF4-FFF2-40B4-BE49-F238E27FC236}">
-                <a16:creationId xmlns:a16="http://schemas.microsoft.com/office/drawing/2014/main" id="{12886852-DDAB-44FF-A2BF-99DFD18FEEC5}"/>
+                <a16:creationId xmlns:a16="http://schemas.microsoft.com/office/drawing/2014/main" id="{FDA2BC9B-2555-4431-80D8-D1EC9F417A1B}"/>
               </a:ext>
             </a:extLst>
           </p:cNvPr>
@@ -10737,7 +10737,7 @@
           <p:cNvPr id="6" name="">
             <a:extLst xmlns:a="http://schemas.openxmlformats.org/drawingml/2006/main">
               <a:ext uri="{FF2B5EF4-FFF2-40B4-BE49-F238E27FC236}">
-                <a16:creationId xmlns:a16="http://schemas.microsoft.com/office/drawing/2014/main" id="{9BFE86D4-6115-428F-9E75-7E8BAC4D9BB7}"/>
+                <a16:creationId xmlns:a16="http://schemas.microsoft.com/office/drawing/2014/main" id="{FD354FBA-3D97-49BD-97A8-72817150A54B}"/>
               </a:ext>
             </a:extLst>
           </p:cNvPr>
@@ -10895,7 +10895,7 @@
           <p:cNvPr id="7" name="">
             <a:extLst xmlns:a="http://schemas.openxmlformats.org/drawingml/2006/main">
               <a:ext uri="{FF2B5EF4-FFF2-40B4-BE49-F238E27FC236}">
-                <a16:creationId xmlns:a16="http://schemas.microsoft.com/office/drawing/2014/main" id="{D31BB8BB-A277-4322-AF4D-D71187847F5A}"/>
+                <a16:creationId xmlns:a16="http://schemas.microsoft.com/office/drawing/2014/main" id="{E886A9E9-6309-41F2-BC49-E20514D90760}"/>
               </a:ext>
             </a:extLst>
           </p:cNvPr>
@@ -11127,7 +11127,7 @@
           <p:cNvPr id="8" name="">
             <a:extLst xmlns:a="http://schemas.openxmlformats.org/drawingml/2006/main">
               <a:ext uri="{FF2B5EF4-FFF2-40B4-BE49-F238E27FC236}">
-                <a16:creationId xmlns:a16="http://schemas.microsoft.com/office/drawing/2014/main" id="{6A9CB35F-47F8-4B60-8F6D-F0BE7664BCB8}"/>
+                <a16:creationId xmlns:a16="http://schemas.microsoft.com/office/drawing/2014/main" id="{338F78C3-42F7-46E5-9DAE-6C49AA436513}"/>
               </a:ext>
             </a:extLst>
           </p:cNvPr>
@@ -11283,7 +11283,7 @@
     </p:spTree>
     <p:extLst>
       <p:ext uri="{BB962C8B-B14F-4D97-AF65-F5344CB8AC3E}">
-        <p14:creationId xmlns:p14="http://schemas.microsoft.com/office/powerpoint/2010/main" val="637311950"/>
+        <p14:creationId xmlns:p14="http://schemas.microsoft.com/office/powerpoint/2010/main" val="460290161"/>
       </p:ext>
     </p:extLst>
   </p:cSld>
@@ -11314,7 +11314,7 @@
           <p:cNvPr id="8" name="">
             <a:extLst xmlns:a="http://schemas.openxmlformats.org/drawingml/2006/main">
               <a:ext uri="{FF2B5EF4-FFF2-40B4-BE49-F238E27FC236}">
-                <a16:creationId xmlns:a16="http://schemas.microsoft.com/office/drawing/2014/main" id="{C26FBD58-2D23-40F6-B0A1-3D0DD7513E61}"/>
+                <a16:creationId xmlns:a16="http://schemas.microsoft.com/office/drawing/2014/main" id="{3E5F313C-B14D-4B9D-AA41-C24536D60716}"/>
               </a:ext>
             </a:extLst>
           </p:cNvPr>
@@ -11472,7 +11472,7 @@
           <p:cNvPr id="2" name="">
             <a:extLst xmlns:a="http://schemas.openxmlformats.org/drawingml/2006/main">
               <a:ext uri="{FF2B5EF4-FFF2-40B4-BE49-F238E27FC236}">
-                <a16:creationId xmlns:a16="http://schemas.microsoft.com/office/drawing/2014/main" id="{9879B461-BD6D-4734-81DC-5D44DA7D4A52}"/>
+                <a16:creationId xmlns:a16="http://schemas.microsoft.com/office/drawing/2014/main" id="{8A8432CD-3C2E-402F-9AD5-7F5DD93E152C}"/>
               </a:ext>
             </a:extLst>
           </p:cNvPr>
@@ -11630,7 +11630,7 @@
           <p:cNvPr id="3" name="">
             <a:extLst xmlns:a="http://schemas.openxmlformats.org/drawingml/2006/main">
               <a:ext uri="{FF2B5EF4-FFF2-40B4-BE49-F238E27FC236}">
-                <a16:creationId xmlns:a16="http://schemas.microsoft.com/office/drawing/2014/main" id="{65F6FAC4-67D1-4EC2-B790-1D3BB08FF9D7}"/>
+                <a16:creationId xmlns:a16="http://schemas.microsoft.com/office/drawing/2014/main" id="{75B01EC8-6CC1-49E5-8E48-E61D14E9EC6B}"/>
               </a:ext>
             </a:extLst>
           </p:cNvPr>
@@ -11788,7 +11788,7 @@
           <p:cNvPr id="4" name="">
             <a:extLst xmlns:a="http://schemas.openxmlformats.org/drawingml/2006/main">
               <a:ext uri="{FF2B5EF4-FFF2-40B4-BE49-F238E27FC236}">
-                <a16:creationId xmlns:a16="http://schemas.microsoft.com/office/drawing/2014/main" id="{1B67F17E-F90E-4018-98A0-C9CDEE33AE7A}"/>
+                <a16:creationId xmlns:a16="http://schemas.microsoft.com/office/drawing/2014/main" id="{7777EBBC-43BF-4492-BCA6-0E0F8AD843EA}"/>
               </a:ext>
             </a:extLst>
           </p:cNvPr>
@@ -11969,7 +11969,7 @@
           <p:cNvPr id="5" name="">
             <a:extLst xmlns:a="http://schemas.openxmlformats.org/drawingml/2006/main">
               <a:ext uri="{FF2B5EF4-FFF2-40B4-BE49-F238E27FC236}">
-                <a16:creationId xmlns:a16="http://schemas.microsoft.com/office/drawing/2014/main" id="{F716FA96-BD47-49A4-BA5B-D6D8431824A3}"/>
+                <a16:creationId xmlns:a16="http://schemas.microsoft.com/office/drawing/2014/main" id="{59DBD693-FA50-4E33-8ADE-867F779D615F}"/>
               </a:ext>
             </a:extLst>
           </p:cNvPr>
@@ -12150,7 +12150,7 @@
           <p:cNvPr id="6" name="">
             <a:extLst xmlns:a="http://schemas.openxmlformats.org/drawingml/2006/main">
               <a:ext uri="{FF2B5EF4-FFF2-40B4-BE49-F238E27FC236}">
-                <a16:creationId xmlns:a16="http://schemas.microsoft.com/office/drawing/2014/main" id="{0EB9C67C-04D2-4B0C-A8C9-C4B03D60A5A4}"/>
+                <a16:creationId xmlns:a16="http://schemas.microsoft.com/office/drawing/2014/main" id="{A1BE775A-E28F-4DF2-8AB0-F323BB443DB9}"/>
               </a:ext>
             </a:extLst>
           </p:cNvPr>
@@ -12308,7 +12308,7 @@
           <p:cNvPr id="7" name="">
             <a:extLst xmlns:a="http://schemas.openxmlformats.org/drawingml/2006/main">
               <a:ext uri="{FF2B5EF4-FFF2-40B4-BE49-F238E27FC236}">
-                <a16:creationId xmlns:a16="http://schemas.microsoft.com/office/drawing/2014/main" id="{999031A5-6461-4228-A84C-7CA32703ADBF}"/>
+                <a16:creationId xmlns:a16="http://schemas.microsoft.com/office/drawing/2014/main" id="{444E5EDC-57A7-49DA-B385-5B4B033A75C7}"/>
               </a:ext>
             </a:extLst>
           </p:cNvPr>
@@ -12464,7 +12464,7 @@
     </p:spTree>
     <p:extLst>
       <p:ext uri="{BB962C8B-B14F-4D97-AF65-F5344CB8AC3E}">
-        <p14:creationId xmlns:p14="http://schemas.microsoft.com/office/powerpoint/2010/main" val="893988706"/>
+        <p14:creationId xmlns:p14="http://schemas.microsoft.com/office/powerpoint/2010/main" val="1648192064"/>
       </p:ext>
     </p:extLst>
   </p:cSld>
@@ -12495,7 +12495,7 @@
           <p:cNvPr id="6" name="">
             <a:extLst xmlns:a="http://schemas.openxmlformats.org/drawingml/2006/main">
               <a:ext uri="{FF2B5EF4-FFF2-40B4-BE49-F238E27FC236}">
-                <a16:creationId xmlns:a16="http://schemas.microsoft.com/office/drawing/2014/main" id="{A08ACC4C-95C4-4E43-A1BA-1AA42FEDD9F8}"/>
+                <a16:creationId xmlns:a16="http://schemas.microsoft.com/office/drawing/2014/main" id="{5A508A50-326B-4641-BCEF-FC688BE10A03}"/>
               </a:ext>
             </a:extLst>
           </p:cNvPr>
@@ -12653,7 +12653,7 @@
           <p:cNvPr id="2" name="">
             <a:extLst xmlns:a="http://schemas.openxmlformats.org/drawingml/2006/main">
               <a:ext uri="{FF2B5EF4-FFF2-40B4-BE49-F238E27FC236}">
-                <a16:creationId xmlns:a16="http://schemas.microsoft.com/office/drawing/2014/main" id="{09FB06BD-2B1B-46BD-A203-EDFBA389E378}"/>
+                <a16:creationId xmlns:a16="http://schemas.microsoft.com/office/drawing/2014/main" id="{FCF8B64B-0E5F-477E-A8CF-92EA631F512D}"/>
               </a:ext>
             </a:extLst>
           </p:cNvPr>
@@ -12811,7 +12811,7 @@
           <p:cNvPr id="3" name="">
             <a:extLst xmlns:a="http://schemas.openxmlformats.org/drawingml/2006/main">
               <a:ext uri="{FF2B5EF4-FFF2-40B4-BE49-F238E27FC236}">
-                <a16:creationId xmlns:a16="http://schemas.microsoft.com/office/drawing/2014/main" id="{A43034E4-54A1-4F77-B046-23EF6E68D478}"/>
+                <a16:creationId xmlns:a16="http://schemas.microsoft.com/office/drawing/2014/main" id="{72135C44-662B-4340-A9A2-D9201DC28EC8}"/>
               </a:ext>
             </a:extLst>
           </p:cNvPr>
@@ -12969,7 +12969,7 @@
           <p:cNvPr id="4" name="">
             <a:extLst xmlns:a="http://schemas.openxmlformats.org/drawingml/2006/main">
               <a:ext uri="{FF2B5EF4-FFF2-40B4-BE49-F238E27FC236}">
-                <a16:creationId xmlns:a16="http://schemas.microsoft.com/office/drawing/2014/main" id="{4242EDE0-9649-4E0B-9525-9B296A47C215}"/>
+                <a16:creationId xmlns:a16="http://schemas.microsoft.com/office/drawing/2014/main" id="{09560334-602E-4A62-8D5F-041B105220CF}"/>
               </a:ext>
             </a:extLst>
           </p:cNvPr>
@@ -13480,7 +13480,7 @@
           <p:cNvPr id="5" name="">
             <a:extLst xmlns:a="http://schemas.openxmlformats.org/drawingml/2006/main">
               <a:ext uri="{FF2B5EF4-FFF2-40B4-BE49-F238E27FC236}">
-                <a16:creationId xmlns:a16="http://schemas.microsoft.com/office/drawing/2014/main" id="{4C19CA8E-A153-4241-9AD2-8C5752B7AEDA}"/>
+                <a16:creationId xmlns:a16="http://schemas.microsoft.com/office/drawing/2014/main" id="{35A480BE-8072-4A6E-8A7E-57B6A7E505BC}"/>
               </a:ext>
             </a:extLst>
           </p:cNvPr>
@@ -13636,7 +13636,7 @@
     </p:spTree>
     <p:extLst>
       <p:ext uri="{BB962C8B-B14F-4D97-AF65-F5344CB8AC3E}">
-        <p14:creationId xmlns:p14="http://schemas.microsoft.com/office/powerpoint/2010/main" val="608013160"/>
+        <p14:creationId xmlns:p14="http://schemas.microsoft.com/office/powerpoint/2010/main" val="1550385993"/>
       </p:ext>
     </p:extLst>
   </p:cSld>
@@ -13667,7 +13667,7 @@
           <p:cNvPr id="6" name="">
             <a:extLst xmlns:a="http://schemas.openxmlformats.org/drawingml/2006/main">
               <a:ext uri="{FF2B5EF4-FFF2-40B4-BE49-F238E27FC236}">
-                <a16:creationId xmlns:a16="http://schemas.microsoft.com/office/drawing/2014/main" id="{B49FDEA8-8858-4B1D-94E6-9611EAC50465}"/>
+                <a16:creationId xmlns:a16="http://schemas.microsoft.com/office/drawing/2014/main" id="{7067D4C4-2086-4A3C-9F24-80CA7575FADE}"/>
               </a:ext>
             </a:extLst>
           </p:cNvPr>
@@ -13825,7 +13825,7 @@
           <p:cNvPr id="2" name="">
             <a:extLst xmlns:a="http://schemas.openxmlformats.org/drawingml/2006/main">
               <a:ext uri="{FF2B5EF4-FFF2-40B4-BE49-F238E27FC236}">
-                <a16:creationId xmlns:a16="http://schemas.microsoft.com/office/drawing/2014/main" id="{8CC02A9E-985F-4E34-A571-500D357053C2}"/>
+                <a16:creationId xmlns:a16="http://schemas.microsoft.com/office/drawing/2014/main" id="{C78C6E64-3139-4356-9FD4-F54963C2E6FF}"/>
               </a:ext>
             </a:extLst>
           </p:cNvPr>
@@ -13983,7 +13983,7 @@
           <p:cNvPr id="3" name="">
             <a:extLst xmlns:a="http://schemas.openxmlformats.org/drawingml/2006/main">
               <a:ext uri="{FF2B5EF4-FFF2-40B4-BE49-F238E27FC236}">
-                <a16:creationId xmlns:a16="http://schemas.microsoft.com/office/drawing/2014/main" id="{A5F55941-2943-4007-982E-57E0CF42F687}"/>
+                <a16:creationId xmlns:a16="http://schemas.microsoft.com/office/drawing/2014/main" id="{F220334C-0D04-44E3-86A6-BEC1A44B4EE0}"/>
               </a:ext>
             </a:extLst>
           </p:cNvPr>
@@ -14141,7 +14141,7 @@
           <p:cNvPr id="4" name="">
             <a:extLst xmlns:a="http://schemas.openxmlformats.org/drawingml/2006/main">
               <a:ext uri="{FF2B5EF4-FFF2-40B4-BE49-F238E27FC236}">
-                <a16:creationId xmlns:a16="http://schemas.microsoft.com/office/drawing/2014/main" id="{71D0DB07-EC97-49AB-A828-88745F2545A7}"/>
+                <a16:creationId xmlns:a16="http://schemas.microsoft.com/office/drawing/2014/main" id="{5CE52BEF-1369-4D33-9318-E0395700EFB9}"/>
               </a:ext>
             </a:extLst>
           </p:cNvPr>
@@ -14821,7 +14821,7 @@
           <p:cNvPr id="5" name="">
             <a:extLst xmlns:a="http://schemas.openxmlformats.org/drawingml/2006/main">
               <a:ext uri="{FF2B5EF4-FFF2-40B4-BE49-F238E27FC236}">
-                <a16:creationId xmlns:a16="http://schemas.microsoft.com/office/drawing/2014/main" id="{C98DA1EF-4608-456F-9433-672505E64CC6}"/>
+                <a16:creationId xmlns:a16="http://schemas.microsoft.com/office/drawing/2014/main" id="{8451C238-811B-4EB4-BF35-450F7AF8A476}"/>
               </a:ext>
             </a:extLst>
           </p:cNvPr>
@@ -14977,7 +14977,7 @@
     </p:spTree>
     <p:extLst>
       <p:ext uri="{BB962C8B-B14F-4D97-AF65-F5344CB8AC3E}">
-        <p14:creationId xmlns:p14="http://schemas.microsoft.com/office/powerpoint/2010/main" val="432041233"/>
+        <p14:creationId xmlns:p14="http://schemas.microsoft.com/office/powerpoint/2010/main" val="1059497474"/>
       </p:ext>
     </p:extLst>
   </p:cSld>
@@ -15008,7 +15008,7 @@
           <p:cNvPr id="11" name="">
             <a:extLst xmlns:a="http://schemas.openxmlformats.org/drawingml/2006/main">
               <a:ext uri="{FF2B5EF4-FFF2-40B4-BE49-F238E27FC236}">
-                <a16:creationId xmlns:a16="http://schemas.microsoft.com/office/drawing/2014/main" id="{E30BA29A-1602-4F81-8933-3BEB9CE5C2C9}"/>
+                <a16:creationId xmlns:a16="http://schemas.microsoft.com/office/drawing/2014/main" id="{048E2FEA-7C45-41D2-92B6-C0D0A4DA1817}"/>
               </a:ext>
             </a:extLst>
           </p:cNvPr>
@@ -15166,7 +15166,7 @@
           <p:cNvPr id="2" name="">
             <a:extLst xmlns:a="http://schemas.openxmlformats.org/drawingml/2006/main">
               <a:ext uri="{FF2B5EF4-FFF2-40B4-BE49-F238E27FC236}">
-                <a16:creationId xmlns:a16="http://schemas.microsoft.com/office/drawing/2014/main" id="{AEADB103-FDC9-46C3-8242-C6269E5592B4}"/>
+                <a16:creationId xmlns:a16="http://schemas.microsoft.com/office/drawing/2014/main" id="{781847A0-9667-483E-9AEF-EBE6A1C1556E}"/>
               </a:ext>
             </a:extLst>
           </p:cNvPr>
@@ -15324,7 +15324,7 @@
           <p:cNvPr id="3" name="">
             <a:extLst xmlns:a="http://schemas.openxmlformats.org/drawingml/2006/main">
               <a:ext uri="{FF2B5EF4-FFF2-40B4-BE49-F238E27FC236}">
-                <a16:creationId xmlns:a16="http://schemas.microsoft.com/office/drawing/2014/main" id="{F6E4432B-0AA7-499C-9D18-F23696E8278F}"/>
+                <a16:creationId xmlns:a16="http://schemas.microsoft.com/office/drawing/2014/main" id="{479C76C8-0342-4F72-A681-5F1CE6F52F79}"/>
               </a:ext>
             </a:extLst>
           </p:cNvPr>
@@ -15482,7 +15482,7 @@
           <p:cNvPr id="4" name="">
             <a:extLst xmlns:a="http://schemas.openxmlformats.org/drawingml/2006/main">
               <a:ext uri="{FF2B5EF4-FFF2-40B4-BE49-F238E27FC236}">
-                <a16:creationId xmlns:a16="http://schemas.microsoft.com/office/drawing/2014/main" id="{16AF83A1-0FAF-49FC-BE26-327C653C3127}"/>
+                <a16:creationId xmlns:a16="http://schemas.microsoft.com/office/drawing/2014/main" id="{EE8DBD78-E4E8-4870-80DD-1EF161D12779}"/>
               </a:ext>
             </a:extLst>
           </p:cNvPr>
@@ -15640,7 +15640,7 @@
           <p:cNvPr id="5" name="">
             <a:extLst xmlns:a="http://schemas.openxmlformats.org/drawingml/2006/main">
               <a:ext uri="{FF2B5EF4-FFF2-40B4-BE49-F238E27FC236}">
-                <a16:creationId xmlns:a16="http://schemas.microsoft.com/office/drawing/2014/main" id="{1E09A786-4E16-422B-82CD-A925485C7DF2}"/>
+                <a16:creationId xmlns:a16="http://schemas.microsoft.com/office/drawing/2014/main" id="{6A1DDC29-1F22-4969-A4E5-7E87965BFDA5}"/>
               </a:ext>
             </a:extLst>
           </p:cNvPr>
@@ -15798,7 +15798,7 @@
           <p:cNvPr id="6" name="">
             <a:extLst xmlns:a="http://schemas.openxmlformats.org/drawingml/2006/main">
               <a:ext uri="{FF2B5EF4-FFF2-40B4-BE49-F238E27FC236}">
-                <a16:creationId xmlns:a16="http://schemas.microsoft.com/office/drawing/2014/main" id="{CABC07C9-998D-495F-87C8-AC051515FB5C}"/>
+                <a16:creationId xmlns:a16="http://schemas.microsoft.com/office/drawing/2014/main" id="{FCF767FA-FCCA-4B09-A7AC-90CB3DFD9127}"/>
               </a:ext>
             </a:extLst>
           </p:cNvPr>
@@ -15956,7 +15956,7 @@
           <p:cNvPr id="7" name="">
             <a:extLst xmlns:a="http://schemas.openxmlformats.org/drawingml/2006/main">
               <a:ext uri="{FF2B5EF4-FFF2-40B4-BE49-F238E27FC236}">
-                <a16:creationId xmlns:a16="http://schemas.microsoft.com/office/drawing/2014/main" id="{EF4C9526-A015-4300-8E60-7A6BE75024F3}"/>
+                <a16:creationId xmlns:a16="http://schemas.microsoft.com/office/drawing/2014/main" id="{0CE46C58-9DAD-487B-AEC1-60B6281DDFA8}"/>
               </a:ext>
             </a:extLst>
           </p:cNvPr>
@@ -16114,7 +16114,7 @@
           <p:cNvPr id="8" name="">
             <a:extLst xmlns:a="http://schemas.openxmlformats.org/drawingml/2006/main">
               <a:ext uri="{FF2B5EF4-FFF2-40B4-BE49-F238E27FC236}">
-                <a16:creationId xmlns:a16="http://schemas.microsoft.com/office/drawing/2014/main" id="{FDFC1751-B137-4067-B604-90BDDE6E3C5C}"/>
+                <a16:creationId xmlns:a16="http://schemas.microsoft.com/office/drawing/2014/main" id="{40D90C23-A055-4A9C-8204-9C82DA9B3327}"/>
               </a:ext>
             </a:extLst>
           </p:cNvPr>
@@ -16272,7 +16272,7 @@
           <p:cNvPr id="9" name="">
             <a:extLst xmlns:a="http://schemas.openxmlformats.org/drawingml/2006/main">
               <a:ext uri="{FF2B5EF4-FFF2-40B4-BE49-F238E27FC236}">
-                <a16:creationId xmlns:a16="http://schemas.microsoft.com/office/drawing/2014/main" id="{1A97CD62-DFDE-4173-8F5F-784EB90B313C}"/>
+                <a16:creationId xmlns:a16="http://schemas.microsoft.com/office/drawing/2014/main" id="{48A831D5-4205-48D2-B7E6-A188B2880EAC}"/>
               </a:ext>
             </a:extLst>
           </p:cNvPr>
@@ -16430,7 +16430,7 @@
           <p:cNvPr id="10" name="">
             <a:extLst xmlns:a="http://schemas.openxmlformats.org/drawingml/2006/main">
               <a:ext uri="{FF2B5EF4-FFF2-40B4-BE49-F238E27FC236}">
-                <a16:creationId xmlns:a16="http://schemas.microsoft.com/office/drawing/2014/main" id="{24320D4D-16CF-4EC7-B98A-6539ACBF21D2}"/>
+                <a16:creationId xmlns:a16="http://schemas.microsoft.com/office/drawing/2014/main" id="{501FBF4A-CB29-4453-B39C-500B4CC6E6AA}"/>
               </a:ext>
             </a:extLst>
           </p:cNvPr>
@@ -16586,7 +16586,7 @@
     </p:spTree>
     <p:extLst>
       <p:ext uri="{BB962C8B-B14F-4D97-AF65-F5344CB8AC3E}">
-        <p14:creationId xmlns:p14="http://schemas.microsoft.com/office/powerpoint/2010/main" val="800219940"/>
+        <p14:creationId xmlns:p14="http://schemas.microsoft.com/office/powerpoint/2010/main" val="515843579"/>
       </p:ext>
     </p:extLst>
   </p:cSld>
@@ -16617,7 +16617,7 @@
           <p:cNvPr id="8" name="">
             <a:extLst xmlns:a="http://schemas.openxmlformats.org/drawingml/2006/main">
               <a:ext uri="{FF2B5EF4-FFF2-40B4-BE49-F238E27FC236}">
-                <a16:creationId xmlns:a16="http://schemas.microsoft.com/office/drawing/2014/main" id="{A3E48E2D-E610-4EB5-86A0-614D35D570B4}"/>
+                <a16:creationId xmlns:a16="http://schemas.microsoft.com/office/drawing/2014/main" id="{89DF12A9-2A03-4CF4-90A3-6D8F7686A442}"/>
               </a:ext>
             </a:extLst>
           </p:cNvPr>
@@ -16775,7 +16775,7 @@
           <p:cNvPr id="2" name="">
             <a:extLst xmlns:a="http://schemas.openxmlformats.org/drawingml/2006/main">
               <a:ext uri="{FF2B5EF4-FFF2-40B4-BE49-F238E27FC236}">
-                <a16:creationId xmlns:a16="http://schemas.microsoft.com/office/drawing/2014/main" id="{FD21B11C-B53C-4AF4-AD07-0C07F6966F69}"/>
+                <a16:creationId xmlns:a16="http://schemas.microsoft.com/office/drawing/2014/main" id="{2482F5C5-F93F-49C2-B51B-892C2A7DA2DA}"/>
               </a:ext>
             </a:extLst>
           </p:cNvPr>
@@ -16933,7 +16933,7 @@
           <p:cNvPr id="3" name="">
             <a:extLst xmlns:a="http://schemas.openxmlformats.org/drawingml/2006/main">
               <a:ext uri="{FF2B5EF4-FFF2-40B4-BE49-F238E27FC236}">
-                <a16:creationId xmlns:a16="http://schemas.microsoft.com/office/drawing/2014/main" id="{EF8473CB-5F57-4580-AE1C-0FFB2E021747}"/>
+                <a16:creationId xmlns:a16="http://schemas.microsoft.com/office/drawing/2014/main" id="{C7C919F5-6770-4B31-8910-3A30E60B0DBD}"/>
               </a:ext>
             </a:extLst>
           </p:cNvPr>
@@ -17091,7 +17091,7 @@
           <p:cNvPr id="4" name="">
             <a:extLst xmlns:a="http://schemas.openxmlformats.org/drawingml/2006/main">
               <a:ext uri="{FF2B5EF4-FFF2-40B4-BE49-F238E27FC236}">
-                <a16:creationId xmlns:a16="http://schemas.microsoft.com/office/drawing/2014/main" id="{1FA57CC9-C084-41BB-B7C0-926D03F805CE}"/>
+                <a16:creationId xmlns:a16="http://schemas.microsoft.com/office/drawing/2014/main" id="{05D3E87A-FACC-4D73-BF97-FB7E45B397AB}"/>
               </a:ext>
             </a:extLst>
           </p:cNvPr>
@@ -17249,7 +17249,7 @@
           <p:cNvPr id="5" name="">
             <a:extLst xmlns:a="http://schemas.openxmlformats.org/drawingml/2006/main">
               <a:ext uri="{FF2B5EF4-FFF2-40B4-BE49-F238E27FC236}">
-                <a16:creationId xmlns:a16="http://schemas.microsoft.com/office/drawing/2014/main" id="{C7F2DFBC-0E89-4454-8E56-5EC5E852D3B8}"/>
+                <a16:creationId xmlns:a16="http://schemas.microsoft.com/office/drawing/2014/main" id="{7FADD325-C092-4426-A6F3-DB885BCA6C2F}"/>
               </a:ext>
             </a:extLst>
           </p:cNvPr>
@@ -17397,7 +17397,7 @@
                 <a:ea typeface="Arial"/>
                 <a:cs typeface="Arial"/>
               </a:rPr>
-              <a:t>Public map and pilot applications</a:t>
+              <a:t>Mobile search and road-route preview</a:t>
             </a:r>
           </a:p>
           <a:p xmlns:a="http://schemas.openxmlformats.org/drawingml/2006/main">
@@ -17425,7 +17425,7 @@
                 <a:ea typeface="Arial"/>
                 <a:cs typeface="Arial"/>
               </a:rPr>
-              <a:t>Private account and support flows</a:t>
+              <a:t>Photo and GPS review workflow</a:t>
             </a:r>
           </a:p>
           <a:p xmlns:a="http://schemas.openxmlformats.org/drawingml/2006/main">
@@ -17453,7 +17453,7 @@
                 <a:ea typeface="Arial"/>
                 <a:cs typeface="Arial"/>
               </a:rPr>
-              <a:t>Operator review and session records</a:t>
+              <a:t>Account, support and session records</a:t>
             </a:r>
           </a:p>
           <a:p xmlns:a="http://schemas.openxmlformats.org/drawingml/2006/main">
@@ -17481,7 +17481,7 @@
                 <a:ea typeface="Arial"/>
                 <a:cs typeface="Arial"/>
               </a:rPr>
-              <a:t>Tested reservation/payment safeguards</a:t>
+              <a:t>Tested ownership/payment safeguards</a:t>
             </a:r>
           </a:p>
         </p:txBody>
@@ -17491,7 +17491,7 @@
           <p:cNvPr id="6" name="">
             <a:extLst xmlns:a="http://schemas.openxmlformats.org/drawingml/2006/main">
               <a:ext uri="{FF2B5EF4-FFF2-40B4-BE49-F238E27FC236}">
-                <a16:creationId xmlns:a16="http://schemas.microsoft.com/office/drawing/2014/main" id="{982D4129-C36D-4438-BE17-D0BC327CC980}"/>
+                <a16:creationId xmlns:a16="http://schemas.microsoft.com/office/drawing/2014/main" id="{7A7A90C9-D6B2-4B17-B91A-DF2ED83042FB}"/>
               </a:ext>
             </a:extLst>
           </p:cNvPr>
@@ -17649,7 +17649,7 @@
           <p:cNvPr id="7" name="">
             <a:extLst xmlns:a="http://schemas.openxmlformats.org/drawingml/2006/main">
               <a:ext uri="{FF2B5EF4-FFF2-40B4-BE49-F238E27FC236}">
-                <a16:creationId xmlns:a16="http://schemas.microsoft.com/office/drawing/2014/main" id="{0807790B-6128-4114-9166-0ED8038C3645}"/>
+                <a16:creationId xmlns:a16="http://schemas.microsoft.com/office/drawing/2014/main" id="{61B142A4-C60D-4829-9DE1-13BF7EA37D76}"/>
               </a:ext>
             </a:extLst>
           </p:cNvPr>
@@ -17825,7 +17825,7 @@
                 <a:ea typeface="Arial"/>
                 <a:cs typeface="Arial"/>
               </a:rPr>
-              <a:t>Production email and Google activation</a:t>
+              <a:t>Production email and routing capacity</a:t>
             </a:r>
           </a:p>
           <a:p xmlns:a="http://schemas.openxmlformats.org/drawingml/2006/main">
@@ -17889,7 +17889,7 @@
     </p:spTree>
     <p:extLst>
       <p:ext uri="{BB962C8B-B14F-4D97-AF65-F5344CB8AC3E}">
-        <p14:creationId xmlns:p14="http://schemas.microsoft.com/office/powerpoint/2010/main" val="1666917033"/>
+        <p14:creationId xmlns:p14="http://schemas.microsoft.com/office/powerpoint/2010/main" val="1019009593"/>
       </p:ext>
     </p:extLst>
   </p:cSld>

</xml_diff>